<commit_message>
Changed axis line widths to 1 pt in PPT
</commit_message>
<xml_diff>
--- a/output/supplemental_figures/FigS2.pptx
+++ b/output/supplemental_figures/FigS2.pptx
@@ -3192,8 +3192,8 @@
           </p:nvSpPr>
           <p:spPr>
             <a:xfrm>
-              <a:off x="2434857" y="1473224"/>
-              <a:ext cx="3211464" cy="4505900"/>
+              <a:off x="2434712" y="1473167"/>
+              <a:ext cx="3211537" cy="4506093"/>
             </a:xfrm>
             <a:prstGeom prst="rect">
               <a:avLst/>
@@ -3218,8 +3218,8 @@
           </p:nvSpPr>
           <p:spPr>
             <a:xfrm>
-              <a:off x="2512554" y="5030870"/>
-              <a:ext cx="466180" cy="43542"/>
+              <a:off x="2512410" y="5030966"/>
+              <a:ext cx="466190" cy="43544"/>
             </a:xfrm>
             <a:prstGeom prst="rect">
               <a:avLst/>
@@ -3244,8 +3244,8 @@
           </p:nvSpPr>
           <p:spPr>
             <a:xfrm>
-              <a:off x="2512554" y="5074413"/>
-              <a:ext cx="466180" cy="43542"/>
+              <a:off x="2512410" y="5074510"/>
+              <a:ext cx="466190" cy="43544"/>
             </a:xfrm>
             <a:prstGeom prst="rect">
               <a:avLst/>
@@ -3270,8 +3270,8 @@
           </p:nvSpPr>
           <p:spPr>
             <a:xfrm>
-              <a:off x="2512554" y="5117955"/>
-              <a:ext cx="466180" cy="861169"/>
+              <a:off x="2512410" y="5118054"/>
+              <a:ext cx="466190" cy="861206"/>
             </a:xfrm>
             <a:prstGeom prst="rect">
               <a:avLst/>
@@ -3296,8 +3296,8 @@
           </p:nvSpPr>
           <p:spPr>
             <a:xfrm>
-              <a:off x="3030532" y="5321152"/>
-              <a:ext cx="466180" cy="42332"/>
+              <a:off x="3030400" y="5321260"/>
+              <a:ext cx="466190" cy="42334"/>
             </a:xfrm>
             <a:prstGeom prst="rect">
               <a:avLst/>
@@ -3322,8 +3322,8 @@
           </p:nvSpPr>
           <p:spPr>
             <a:xfrm>
-              <a:off x="3030532" y="5363485"/>
-              <a:ext cx="466180" cy="44751"/>
+              <a:off x="3030400" y="5363595"/>
+              <a:ext cx="466190" cy="44753"/>
             </a:xfrm>
             <a:prstGeom prst="rect">
               <a:avLst/>
@@ -3348,8 +3348,8 @@
           </p:nvSpPr>
           <p:spPr>
             <a:xfrm>
-              <a:off x="3030532" y="5408237"/>
-              <a:ext cx="466180" cy="570887"/>
+              <a:off x="3030400" y="5408349"/>
+              <a:ext cx="466190" cy="570912"/>
             </a:xfrm>
             <a:prstGeom prst="rect">
               <a:avLst/>
@@ -3374,8 +3374,8 @@
           </p:nvSpPr>
           <p:spPr>
             <a:xfrm>
-              <a:off x="3548510" y="5559425"/>
-              <a:ext cx="466180" cy="24190"/>
+              <a:off x="3548390" y="5559544"/>
+              <a:ext cx="466190" cy="24191"/>
             </a:xfrm>
             <a:prstGeom prst="rect">
               <a:avLst/>
@@ -3400,8 +3400,8 @@
           </p:nvSpPr>
           <p:spPr>
             <a:xfrm>
-              <a:off x="3548510" y="5583616"/>
-              <a:ext cx="466180" cy="39913"/>
+              <a:off x="3548390" y="5583735"/>
+              <a:ext cx="466190" cy="39915"/>
             </a:xfrm>
             <a:prstGeom prst="rect">
               <a:avLst/>
@@ -3426,8 +3426,8 @@
           </p:nvSpPr>
           <p:spPr>
             <a:xfrm>
-              <a:off x="3548510" y="5623529"/>
-              <a:ext cx="466180" cy="355595"/>
+              <a:off x="3548390" y="5623650"/>
+              <a:ext cx="466190" cy="355610"/>
             </a:xfrm>
             <a:prstGeom prst="rect">
               <a:avLst/>
@@ -3452,8 +3452,8 @@
           </p:nvSpPr>
           <p:spPr>
             <a:xfrm>
-              <a:off x="4066488" y="4426117"/>
-              <a:ext cx="466180" cy="70151"/>
+              <a:off x="4066380" y="4426186"/>
+              <a:ext cx="466190" cy="70154"/>
             </a:xfrm>
             <a:prstGeom prst="rect">
               <a:avLst/>
@@ -3478,8 +3478,8 @@
           </p:nvSpPr>
           <p:spPr>
             <a:xfrm>
-              <a:off x="4066488" y="4496268"/>
-              <a:ext cx="466180" cy="97970"/>
+              <a:off x="4066380" y="4496341"/>
+              <a:ext cx="466190" cy="97974"/>
             </a:xfrm>
             <a:prstGeom prst="rect">
               <a:avLst/>
@@ -3504,8 +3504,8 @@
           </p:nvSpPr>
           <p:spPr>
             <a:xfrm>
-              <a:off x="4066488" y="4594238"/>
-              <a:ext cx="466180" cy="1384886"/>
+              <a:off x="4066380" y="4594315"/>
+              <a:ext cx="466190" cy="1384945"/>
             </a:xfrm>
             <a:prstGeom prst="rect">
               <a:avLst/>
@@ -3530,8 +3530,8 @@
           </p:nvSpPr>
           <p:spPr>
             <a:xfrm>
-              <a:off x="4584467" y="5171173"/>
-              <a:ext cx="466180" cy="26609"/>
+              <a:off x="4584370" y="5171275"/>
+              <a:ext cx="466190" cy="26610"/>
             </a:xfrm>
             <a:prstGeom prst="rect">
               <a:avLst/>
@@ -3556,8 +3556,8 @@
           </p:nvSpPr>
           <p:spPr>
             <a:xfrm>
-              <a:off x="4584467" y="5197783"/>
-              <a:ext cx="466180" cy="59265"/>
+              <a:off x="4584370" y="5197885"/>
+              <a:ext cx="466190" cy="59268"/>
             </a:xfrm>
             <a:prstGeom prst="rect">
               <a:avLst/>
@@ -3582,8 +3582,8 @@
           </p:nvSpPr>
           <p:spPr>
             <a:xfrm>
-              <a:off x="4584467" y="5257048"/>
-              <a:ext cx="466180" cy="722076"/>
+              <a:off x="4584370" y="5257154"/>
+              <a:ext cx="466190" cy="722107"/>
             </a:xfrm>
             <a:prstGeom prst="rect">
               <a:avLst/>
@@ -3608,8 +3608,8 @@
           </p:nvSpPr>
           <p:spPr>
             <a:xfrm>
-              <a:off x="5102445" y="5195364"/>
-              <a:ext cx="466180" cy="31447"/>
+              <a:off x="5102360" y="5195466"/>
+              <a:ext cx="466190" cy="31448"/>
             </a:xfrm>
             <a:prstGeom prst="rect">
               <a:avLst/>
@@ -3634,8 +3634,8 @@
           </p:nvSpPr>
           <p:spPr>
             <a:xfrm>
-              <a:off x="5102445" y="5226811"/>
-              <a:ext cx="466180" cy="62894"/>
+              <a:off x="5102360" y="5226915"/>
+              <a:ext cx="466190" cy="62897"/>
             </a:xfrm>
             <a:prstGeom prst="rect">
               <a:avLst/>
@@ -3660,8 +3660,8 @@
           </p:nvSpPr>
           <p:spPr>
             <a:xfrm>
-              <a:off x="5102445" y="5289705"/>
-              <a:ext cx="466180" cy="689419"/>
+              <a:off x="5102360" y="5289812"/>
+              <a:ext cx="466190" cy="689448"/>
             </a:xfrm>
             <a:prstGeom prst="rect">
               <a:avLst/>
@@ -3686,14 +3686,13 @@
           </p:nvSpPr>
           <p:spPr>
             <a:xfrm>
-              <a:off x="2434857" y="1473224"/>
-              <a:ext cx="3211464" cy="4505900"/>
-            </a:xfrm>
-            <a:prstGeom prst="rect">
-              <a:avLst/>
-            </a:prstGeom>
-            <a:noFill/>
-            <a:ln w="13550" cap="rnd">
+              <a:off x="2434712" y="1473167"/>
+              <a:ext cx="3211537" cy="4506093"/>
+            </a:xfrm>
+            <a:prstGeom prst="rect">
+              <a:avLst/>
+            </a:prstGeom>
+            <a:ln w="12737" cap="rnd">
               <a:solidFill>
                 <a:srgbClr val="4D4D4D">
                   <a:alpha val="100000"/>
@@ -3717,8 +3716,8 @@
           </p:nvSpPr>
           <p:spPr>
             <a:xfrm>
-              <a:off x="5700322" y="1473224"/>
-              <a:ext cx="3211464" cy="4505900"/>
+              <a:off x="5700249" y="1473167"/>
+              <a:ext cx="3211537" cy="4506093"/>
             </a:xfrm>
             <a:prstGeom prst="rect">
               <a:avLst/>
@@ -3743,8 +3742,8 @@
           </p:nvSpPr>
           <p:spPr>
             <a:xfrm>
-              <a:off x="5778019" y="5307848"/>
-              <a:ext cx="466180" cy="49589"/>
+              <a:off x="5777948" y="5307955"/>
+              <a:ext cx="466190" cy="49591"/>
             </a:xfrm>
             <a:prstGeom prst="rect">
               <a:avLst/>
@@ -3769,8 +3768,8 @@
           </p:nvSpPr>
           <p:spPr>
             <a:xfrm>
-              <a:off x="5778019" y="5357438"/>
-              <a:ext cx="466180" cy="30237"/>
+              <a:off x="5777948" y="5357547"/>
+              <a:ext cx="466190" cy="30238"/>
             </a:xfrm>
             <a:prstGeom prst="rect">
               <a:avLst/>
@@ -3795,8 +3794,8 @@
           </p:nvSpPr>
           <p:spPr>
             <a:xfrm>
-              <a:off x="5778019" y="5387675"/>
-              <a:ext cx="466180" cy="591449"/>
+              <a:off x="5777948" y="5387786"/>
+              <a:ext cx="466190" cy="591474"/>
             </a:xfrm>
             <a:prstGeom prst="rect">
               <a:avLst/>
@@ -3821,8 +3820,8 @@
           </p:nvSpPr>
           <p:spPr>
             <a:xfrm>
-              <a:off x="6295997" y="4496268"/>
-              <a:ext cx="466180" cy="104017"/>
+              <a:off x="6295938" y="4496341"/>
+              <a:ext cx="466190" cy="104022"/>
             </a:xfrm>
             <a:prstGeom prst="rect">
               <a:avLst/>
@@ -3847,8 +3846,8 @@
           </p:nvSpPr>
           <p:spPr>
             <a:xfrm>
-              <a:off x="6295997" y="4600286"/>
-              <a:ext cx="466180" cy="120950"/>
+              <a:off x="6295938" y="4600363"/>
+              <a:ext cx="466190" cy="120955"/>
             </a:xfrm>
             <a:prstGeom prst="rect">
               <a:avLst/>
@@ -3873,8 +3872,8 @@
           </p:nvSpPr>
           <p:spPr>
             <a:xfrm>
-              <a:off x="6295997" y="4721236"/>
-              <a:ext cx="466180" cy="1257888"/>
+              <a:off x="6295938" y="4721319"/>
+              <a:ext cx="466190" cy="1257942"/>
             </a:xfrm>
             <a:prstGeom prst="rect">
               <a:avLst/>
@@ -3899,8 +3898,8 @@
           </p:nvSpPr>
           <p:spPr>
             <a:xfrm>
-              <a:off x="6813975" y="5167545"/>
-              <a:ext cx="466180" cy="60475"/>
+              <a:off x="6813928" y="5167646"/>
+              <a:ext cx="466190" cy="60477"/>
             </a:xfrm>
             <a:prstGeom prst="rect">
               <a:avLst/>
@@ -3925,8 +3924,8 @@
           </p:nvSpPr>
           <p:spPr>
             <a:xfrm>
-              <a:off x="6813975" y="5228020"/>
-              <a:ext cx="466180" cy="41123"/>
+              <a:off x="6813928" y="5228124"/>
+              <a:ext cx="466190" cy="41125"/>
             </a:xfrm>
             <a:prstGeom prst="rect">
               <a:avLst/>
@@ -3951,8 +3950,8 @@
           </p:nvSpPr>
           <p:spPr>
             <a:xfrm>
-              <a:off x="6813975" y="5269143"/>
-              <a:ext cx="466180" cy="709981"/>
+              <a:off x="6813928" y="5269249"/>
+              <a:ext cx="466190" cy="710011"/>
             </a:xfrm>
             <a:prstGeom prst="rect">
               <a:avLst/>
@@ -3977,8 +3976,8 @@
           </p:nvSpPr>
           <p:spPr>
             <a:xfrm>
-              <a:off x="7331953" y="5375580"/>
-              <a:ext cx="466180" cy="47170"/>
+              <a:off x="7331918" y="5375690"/>
+              <a:ext cx="466190" cy="47172"/>
             </a:xfrm>
             <a:prstGeom prst="rect">
               <a:avLst/>
@@ -4003,8 +4002,8 @@
           </p:nvSpPr>
           <p:spPr>
             <a:xfrm>
-              <a:off x="7331953" y="5422751"/>
-              <a:ext cx="466180" cy="26609"/>
+              <a:off x="7331918" y="5422863"/>
+              <a:ext cx="466190" cy="26610"/>
             </a:xfrm>
             <a:prstGeom prst="rect">
               <a:avLst/>
@@ -4029,8 +4028,8 @@
           </p:nvSpPr>
           <p:spPr>
             <a:xfrm>
-              <a:off x="7331953" y="5449360"/>
-              <a:ext cx="466180" cy="529764"/>
+              <a:off x="7331918" y="5449474"/>
+              <a:ext cx="466190" cy="529787"/>
             </a:xfrm>
             <a:prstGeom prst="rect">
               <a:avLst/>
@@ -4055,8 +4054,8 @@
           </p:nvSpPr>
           <p:spPr>
             <a:xfrm>
-              <a:off x="7849932" y="1687791"/>
-              <a:ext cx="466180" cy="191102"/>
+              <a:off x="7849908" y="1687743"/>
+              <a:ext cx="466190" cy="191110"/>
             </a:xfrm>
             <a:prstGeom prst="rect">
               <a:avLst/>
@@ -4081,8 +4080,8 @@
           </p:nvSpPr>
           <p:spPr>
             <a:xfrm>
-              <a:off x="7849932" y="1878893"/>
-              <a:ext cx="466180" cy="214082"/>
+              <a:off x="7849908" y="1878854"/>
+              <a:ext cx="466190" cy="214092"/>
             </a:xfrm>
             <a:prstGeom prst="rect">
               <a:avLst/>
@@ -4107,8 +4106,8 @@
           </p:nvSpPr>
           <p:spPr>
             <a:xfrm>
-              <a:off x="7849932" y="2092976"/>
-              <a:ext cx="466180" cy="3886148"/>
+              <a:off x="7849908" y="2092946"/>
+              <a:ext cx="466190" cy="3886315"/>
             </a:xfrm>
             <a:prstGeom prst="rect">
               <a:avLst/>
@@ -4133,8 +4132,8 @@
           </p:nvSpPr>
           <p:spPr>
             <a:xfrm>
-              <a:off x="8367910" y="2614274"/>
-              <a:ext cx="466180" cy="165702"/>
+              <a:off x="8367897" y="2614266"/>
+              <a:ext cx="466190" cy="165709"/>
             </a:xfrm>
             <a:prstGeom prst="rect">
               <a:avLst/>
@@ -4159,8 +4158,8 @@
           </p:nvSpPr>
           <p:spPr>
             <a:xfrm>
-              <a:off x="8367910" y="2779976"/>
-              <a:ext cx="466180" cy="162074"/>
+              <a:off x="8367897" y="2779975"/>
+              <a:ext cx="466190" cy="162080"/>
             </a:xfrm>
             <a:prstGeom prst="rect">
               <a:avLst/>
@@ -4185,8 +4184,8 @@
           </p:nvSpPr>
           <p:spPr>
             <a:xfrm>
-              <a:off x="8367910" y="2942050"/>
-              <a:ext cx="466180" cy="3037074"/>
+              <a:off x="8367897" y="2942056"/>
+              <a:ext cx="466190" cy="3037204"/>
             </a:xfrm>
             <a:prstGeom prst="rect">
               <a:avLst/>
@@ -4211,14 +4210,13 @@
           </p:nvSpPr>
           <p:spPr>
             <a:xfrm>
-              <a:off x="5700322" y="1473224"/>
-              <a:ext cx="3211464" cy="4505900"/>
-            </a:xfrm>
-            <a:prstGeom prst="rect">
-              <a:avLst/>
-            </a:prstGeom>
-            <a:noFill/>
-            <a:ln w="13550" cap="rnd">
+              <a:off x="5700249" y="1473167"/>
+              <a:ext cx="3211537" cy="4506093"/>
+            </a:xfrm>
+            <a:prstGeom prst="rect">
+              <a:avLst/>
+            </a:prstGeom>
+            <a:ln w="12737" cap="rnd">
               <a:solidFill>
                 <a:srgbClr val="4D4D4D">
                   <a:alpha val="100000"/>
@@ -4236,40 +4234,14 @@
         </p:sp>
         <p:sp>
           <p:nvSpPr>
-            <p:cNvPr id="45" name="rc45"/>
-            <p:cNvSpPr/>
-            <p:nvPr/>
-          </p:nvSpPr>
-          <p:spPr>
-            <a:xfrm>
-              <a:off x="2434857" y="1133119"/>
-              <a:ext cx="3211464" cy="340105"/>
-            </a:xfrm>
-            <a:prstGeom prst="rect">
-              <a:avLst/>
-            </a:prstGeom>
-            <a:solidFill>
-              <a:srgbClr val="FFFFFF">
-                <a:alpha val="100000"/>
-              </a:srgbClr>
-            </a:solidFill>
-          </p:spPr>
-          <p:txBody>
-            <a:bodyPr/>
-            <a:lstStyle/>
-            <a:p/>
-          </p:txBody>
-        </p:sp>
-        <p:sp>
-          <p:nvSpPr>
-            <p:cNvPr id="46" name="tx46"/>
-            <p:cNvSpPr/>
-            <p:nvPr/>
-          </p:nvSpPr>
-          <p:spPr>
-            <a:xfrm>
-              <a:off x="3244284" y="1230431"/>
-              <a:ext cx="1592610" cy="145481"/>
+            <p:cNvPr id="45" name="tx45"/>
+            <p:cNvSpPr/>
+            <p:nvPr/>
+          </p:nvSpPr>
+          <p:spPr>
+            <a:xfrm>
+              <a:off x="3244200" y="1228034"/>
+              <a:ext cx="1592560" cy="147835"/>
             </a:xfrm>
             <a:prstGeom prst="rect">
               <a:avLst/>
@@ -4281,6 +4253,9 @@
             <a:lstStyle/>
             <a:p>
               <a:pPr algn="l" marL="0" marR="0" indent="0">
+                <a:lnSpc>
+                  <a:spcPts val="1600"/>
+                </a:lnSpc>
                 <a:spcBef>
                   <a:spcPts val="0"/>
                 </a:spcBef>
@@ -4289,7 +4264,7 @@
                 </a:spcAft>
               </a:pPr>
               <a:r>
-                <a:rPr sz="1600" i="1" b="0">
+                <a:rPr sz="1600" i="1">
                   <a:solidFill>
                     <a:srgbClr val="1A1A1A">
                       <a:alpha val="100000"/>
@@ -4305,40 +4280,14 @@
         </p:sp>
         <p:sp>
           <p:nvSpPr>
-            <p:cNvPr id="47" name="rc47"/>
-            <p:cNvSpPr/>
-            <p:nvPr/>
-          </p:nvSpPr>
-          <p:spPr>
-            <a:xfrm>
-              <a:off x="5700322" y="1133119"/>
-              <a:ext cx="3211464" cy="340105"/>
-            </a:xfrm>
-            <a:prstGeom prst="rect">
-              <a:avLst/>
-            </a:prstGeom>
-            <a:solidFill>
-              <a:srgbClr val="FFFFFF">
-                <a:alpha val="100000"/>
-              </a:srgbClr>
-            </a:solidFill>
-          </p:spPr>
-          <p:txBody>
-            <a:bodyPr/>
-            <a:lstStyle/>
-            <a:p/>
-          </p:txBody>
-        </p:sp>
-        <p:sp>
-          <p:nvSpPr>
-            <p:cNvPr id="48" name="tx48"/>
-            <p:cNvSpPr/>
-            <p:nvPr/>
-          </p:nvSpPr>
-          <p:spPr>
-            <a:xfrm>
-              <a:off x="6564293" y="1230431"/>
-              <a:ext cx="1483522" cy="145481"/>
+            <p:cNvPr id="46" name="tx46"/>
+            <p:cNvSpPr/>
+            <p:nvPr/>
+          </p:nvSpPr>
+          <p:spPr>
+            <a:xfrm>
+              <a:off x="6560538" y="1188248"/>
+              <a:ext cx="1490960" cy="187622"/>
             </a:xfrm>
             <a:prstGeom prst="rect">
               <a:avLst/>
@@ -4350,6 +4299,9 @@
             <a:lstStyle/>
             <a:p>
               <a:pPr algn="l" marL="0" marR="0" indent="0">
+                <a:lnSpc>
+                  <a:spcPts val="1600"/>
+                </a:lnSpc>
                 <a:spcBef>
                   <a:spcPts val="0"/>
                 </a:spcBef>
@@ -4358,7 +4310,7 @@
                 </a:spcAft>
               </a:pPr>
               <a:r>
-                <a:rPr sz="1600" i="1" b="0">
+                <a:rPr sz="1600" i="1">
                   <a:solidFill>
                     <a:srgbClr val="1A1A1A">
                       <a:alpha val="100000"/>
@@ -4374,13 +4326,13 @@
         </p:sp>
         <p:sp>
           <p:nvSpPr>
-            <p:cNvPr id="49" name="pl49"/>
-            <p:cNvSpPr/>
-            <p:nvPr/>
-          </p:nvSpPr>
-          <p:spPr>
-            <a:xfrm>
-              <a:off x="2745644" y="5979125"/>
+            <p:cNvPr id="47" name="pl47"/>
+            <p:cNvSpPr/>
+            <p:nvPr/>
+          </p:nvSpPr>
+          <p:spPr>
+            <a:xfrm>
+              <a:off x="2745506" y="5979261"/>
               <a:ext cx="0" cy="47447"/>
             </a:xfrm>
             <a:custGeom>
@@ -4396,9 +4348,9 @@
                 </a:path>
               </a:pathLst>
             </a:custGeom>
-            <a:ln w="18478" cap="flat">
+            <a:ln w="12737" cap="flat">
               <a:solidFill>
-                <a:srgbClr val="4D4D4D">
+                <a:srgbClr val="000000">
                   <a:alpha val="100000"/>
                 </a:srgbClr>
               </a:solidFill>
@@ -4414,13 +4366,13 @@
         </p:sp>
         <p:sp>
           <p:nvSpPr>
-            <p:cNvPr id="50" name="pl50"/>
-            <p:cNvSpPr/>
-            <p:nvPr/>
-          </p:nvSpPr>
-          <p:spPr>
-            <a:xfrm>
-              <a:off x="3263622" y="5979125"/>
+            <p:cNvPr id="48" name="pl48"/>
+            <p:cNvSpPr/>
+            <p:nvPr/>
+          </p:nvSpPr>
+          <p:spPr>
+            <a:xfrm>
+              <a:off x="3263496" y="5979261"/>
               <a:ext cx="0" cy="47447"/>
             </a:xfrm>
             <a:custGeom>
@@ -4436,9 +4388,9 @@
                 </a:path>
               </a:pathLst>
             </a:custGeom>
-            <a:ln w="18478" cap="flat">
+            <a:ln w="12737" cap="flat">
               <a:solidFill>
-                <a:srgbClr val="4D4D4D">
+                <a:srgbClr val="000000">
                   <a:alpha val="100000"/>
                 </a:srgbClr>
               </a:solidFill>
@@ -4454,13 +4406,13 @@
         </p:sp>
         <p:sp>
           <p:nvSpPr>
-            <p:cNvPr id="51" name="pl51"/>
-            <p:cNvSpPr/>
-            <p:nvPr/>
-          </p:nvSpPr>
-          <p:spPr>
-            <a:xfrm>
-              <a:off x="3781600" y="5979125"/>
+            <p:cNvPr id="49" name="pl49"/>
+            <p:cNvSpPr/>
+            <p:nvPr/>
+          </p:nvSpPr>
+          <p:spPr>
+            <a:xfrm>
+              <a:off x="3781486" y="5979261"/>
               <a:ext cx="0" cy="47447"/>
             </a:xfrm>
             <a:custGeom>
@@ -4476,9 +4428,9 @@
                 </a:path>
               </a:pathLst>
             </a:custGeom>
-            <a:ln w="18478" cap="flat">
+            <a:ln w="12737" cap="flat">
               <a:solidFill>
-                <a:srgbClr val="4D4D4D">
+                <a:srgbClr val="000000">
                   <a:alpha val="100000"/>
                 </a:srgbClr>
               </a:solidFill>
@@ -4494,13 +4446,13 @@
         </p:sp>
         <p:sp>
           <p:nvSpPr>
-            <p:cNvPr id="52" name="pl52"/>
-            <p:cNvSpPr/>
-            <p:nvPr/>
-          </p:nvSpPr>
-          <p:spPr>
-            <a:xfrm>
-              <a:off x="4299579" y="5979125"/>
+            <p:cNvPr id="50" name="pl50"/>
+            <p:cNvSpPr/>
+            <p:nvPr/>
+          </p:nvSpPr>
+          <p:spPr>
+            <a:xfrm>
+              <a:off x="4299476" y="5979261"/>
               <a:ext cx="0" cy="47447"/>
             </a:xfrm>
             <a:custGeom>
@@ -4516,9 +4468,9 @@
                 </a:path>
               </a:pathLst>
             </a:custGeom>
-            <a:ln w="18478" cap="flat">
+            <a:ln w="12737" cap="flat">
               <a:solidFill>
-                <a:srgbClr val="4D4D4D">
+                <a:srgbClr val="000000">
                   <a:alpha val="100000"/>
                 </a:srgbClr>
               </a:solidFill>
@@ -4534,13 +4486,13 @@
         </p:sp>
         <p:sp>
           <p:nvSpPr>
-            <p:cNvPr id="53" name="pl53"/>
-            <p:cNvSpPr/>
-            <p:nvPr/>
-          </p:nvSpPr>
-          <p:spPr>
-            <a:xfrm>
-              <a:off x="4817557" y="5979125"/>
+            <p:cNvPr id="51" name="pl51"/>
+            <p:cNvSpPr/>
+            <p:nvPr/>
+          </p:nvSpPr>
+          <p:spPr>
+            <a:xfrm>
+              <a:off x="4817465" y="5979261"/>
               <a:ext cx="0" cy="47447"/>
             </a:xfrm>
             <a:custGeom>
@@ -4556,9 +4508,9 @@
                 </a:path>
               </a:pathLst>
             </a:custGeom>
-            <a:ln w="18478" cap="flat">
+            <a:ln w="12737" cap="flat">
               <a:solidFill>
-                <a:srgbClr val="4D4D4D">
+                <a:srgbClr val="000000">
                   <a:alpha val="100000"/>
                 </a:srgbClr>
               </a:solidFill>
@@ -4574,13 +4526,13 @@
         </p:sp>
         <p:sp>
           <p:nvSpPr>
-            <p:cNvPr id="54" name="pl54"/>
-            <p:cNvSpPr/>
-            <p:nvPr/>
-          </p:nvSpPr>
-          <p:spPr>
-            <a:xfrm>
-              <a:off x="5335535" y="5979125"/>
+            <p:cNvPr id="52" name="pl52"/>
+            <p:cNvSpPr/>
+            <p:nvPr/>
+          </p:nvSpPr>
+          <p:spPr>
+            <a:xfrm>
+              <a:off x="5335455" y="5979261"/>
               <a:ext cx="0" cy="47447"/>
             </a:xfrm>
             <a:custGeom>
@@ -4596,9 +4548,9 @@
                 </a:path>
               </a:pathLst>
             </a:custGeom>
-            <a:ln w="18478" cap="flat">
+            <a:ln w="12737" cap="flat">
               <a:solidFill>
-                <a:srgbClr val="4D4D4D">
+                <a:srgbClr val="000000">
                   <a:alpha val="100000"/>
                 </a:srgbClr>
               </a:solidFill>
@@ -4614,14 +4566,14 @@
         </p:sp>
         <p:sp>
           <p:nvSpPr>
-            <p:cNvPr id="55" name="tx55"/>
-            <p:cNvSpPr/>
-            <p:nvPr/>
-          </p:nvSpPr>
-          <p:spPr>
-            <a:xfrm>
-              <a:off x="2660879" y="6064529"/>
-              <a:ext cx="169529" cy="109179"/>
+            <p:cNvPr id="53" name="tx53"/>
+            <p:cNvSpPr/>
+            <p:nvPr/>
+          </p:nvSpPr>
+          <p:spPr>
+            <a:xfrm>
+              <a:off x="2660748" y="6064219"/>
+              <a:ext cx="169515" cy="109537"/>
             </a:xfrm>
             <a:prstGeom prst="rect">
               <a:avLst/>
@@ -4633,6 +4585,9 @@
             <a:lstStyle/>
             <a:p>
               <a:pPr algn="l" marL="0" marR="0" indent="0">
+                <a:lnSpc>
+                  <a:spcPts val="1200"/>
+                </a:lnSpc>
                 <a:spcBef>
                   <a:spcPts val="0"/>
                 </a:spcBef>
@@ -4641,7 +4596,7 @@
                 </a:spcAft>
               </a:pPr>
               <a:r>
-                <a:rPr sz="1200" i="0" b="0">
+                <a:rPr sz="1200">
                   <a:solidFill>
                     <a:srgbClr val="4D4D4D">
                       <a:alpha val="100000"/>
@@ -4657,14 +4612,14 @@
         </p:sp>
         <p:sp>
           <p:nvSpPr>
-            <p:cNvPr id="56" name="tx56"/>
-            <p:cNvSpPr/>
-            <p:nvPr/>
-          </p:nvSpPr>
-          <p:spPr>
-            <a:xfrm>
-              <a:off x="3178857" y="6064529"/>
-              <a:ext cx="169529" cy="109179"/>
+            <p:cNvPr id="54" name="tx54"/>
+            <p:cNvSpPr/>
+            <p:nvPr/>
+          </p:nvSpPr>
+          <p:spPr>
+            <a:xfrm>
+              <a:off x="3178738" y="6064219"/>
+              <a:ext cx="169515" cy="109537"/>
             </a:xfrm>
             <a:prstGeom prst="rect">
               <a:avLst/>
@@ -4676,6 +4631,9 @@
             <a:lstStyle/>
             <a:p>
               <a:pPr algn="l" marL="0" marR="0" indent="0">
+                <a:lnSpc>
+                  <a:spcPts val="1200"/>
+                </a:lnSpc>
                 <a:spcBef>
                   <a:spcPts val="0"/>
                 </a:spcBef>
@@ -4684,7 +4642,7 @@
                 </a:spcAft>
               </a:pPr>
               <a:r>
-                <a:rPr sz="1200" i="0" b="0">
+                <a:rPr sz="1200">
                   <a:solidFill>
                     <a:srgbClr val="4D4D4D">
                       <a:alpha val="100000"/>
@@ -4700,14 +4658,14 @@
         </p:sp>
         <p:sp>
           <p:nvSpPr>
-            <p:cNvPr id="57" name="tx57"/>
-            <p:cNvSpPr/>
-            <p:nvPr/>
-          </p:nvSpPr>
-          <p:spPr>
-            <a:xfrm>
-              <a:off x="3696836" y="6064529"/>
-              <a:ext cx="169529" cy="109179"/>
+            <p:cNvPr id="55" name="tx55"/>
+            <p:cNvSpPr/>
+            <p:nvPr/>
+          </p:nvSpPr>
+          <p:spPr>
+            <a:xfrm>
+              <a:off x="3696728" y="6062284"/>
+              <a:ext cx="169515" cy="111472"/>
             </a:xfrm>
             <a:prstGeom prst="rect">
               <a:avLst/>
@@ -4719,6 +4677,9 @@
             <a:lstStyle/>
             <a:p>
               <a:pPr algn="l" marL="0" marR="0" indent="0">
+                <a:lnSpc>
+                  <a:spcPts val="1200"/>
+                </a:lnSpc>
                 <a:spcBef>
                   <a:spcPts val="0"/>
                 </a:spcBef>
@@ -4727,7 +4688,7 @@
                 </a:spcAft>
               </a:pPr>
               <a:r>
-                <a:rPr sz="1200" i="0" b="0">
+                <a:rPr sz="1200">
                   <a:solidFill>
                     <a:srgbClr val="4D4D4D">
                       <a:alpha val="100000"/>
@@ -4743,14 +4704,14 @@
         </p:sp>
         <p:sp>
           <p:nvSpPr>
-            <p:cNvPr id="58" name="tx58"/>
-            <p:cNvSpPr/>
-            <p:nvPr/>
-          </p:nvSpPr>
-          <p:spPr>
-            <a:xfrm>
-              <a:off x="4214814" y="6064529"/>
-              <a:ext cx="169529" cy="109179"/>
+            <p:cNvPr id="56" name="tx56"/>
+            <p:cNvSpPr/>
+            <p:nvPr/>
+          </p:nvSpPr>
+          <p:spPr>
+            <a:xfrm>
+              <a:off x="4214718" y="6064665"/>
+              <a:ext cx="169515" cy="109091"/>
             </a:xfrm>
             <a:prstGeom prst="rect">
               <a:avLst/>
@@ -4762,6 +4723,9 @@
             <a:lstStyle/>
             <a:p>
               <a:pPr algn="l" marL="0" marR="0" indent="0">
+                <a:lnSpc>
+                  <a:spcPts val="1200"/>
+                </a:lnSpc>
                 <a:spcBef>
                   <a:spcPts val="0"/>
                 </a:spcBef>
@@ -4770,7 +4734,7 @@
                 </a:spcAft>
               </a:pPr>
               <a:r>
-                <a:rPr sz="1200" i="0" b="0">
+                <a:rPr sz="1200">
                   <a:solidFill>
                     <a:srgbClr val="4D4D4D">
                       <a:alpha val="100000"/>
@@ -4786,14 +4750,14 @@
         </p:sp>
         <p:sp>
           <p:nvSpPr>
-            <p:cNvPr id="59" name="tx59"/>
-            <p:cNvSpPr/>
-            <p:nvPr/>
-          </p:nvSpPr>
-          <p:spPr>
-            <a:xfrm>
-              <a:off x="4732792" y="6064529"/>
-              <a:ext cx="169529" cy="109179"/>
+            <p:cNvPr id="57" name="tx57"/>
+            <p:cNvSpPr/>
+            <p:nvPr/>
+          </p:nvSpPr>
+          <p:spPr>
+            <a:xfrm>
+              <a:off x="4732708" y="6062805"/>
+              <a:ext cx="169515" cy="110951"/>
             </a:xfrm>
             <a:prstGeom prst="rect">
               <a:avLst/>
@@ -4805,6 +4769,9 @@
             <a:lstStyle/>
             <a:p>
               <a:pPr algn="l" marL="0" marR="0" indent="0">
+                <a:lnSpc>
+                  <a:spcPts val="1200"/>
+                </a:lnSpc>
                 <a:spcBef>
                   <a:spcPts val="0"/>
                 </a:spcBef>
@@ -4813,7 +4780,7 @@
                 </a:spcAft>
               </a:pPr>
               <a:r>
-                <a:rPr sz="1200" i="0" b="0">
+                <a:rPr sz="1200">
                   <a:solidFill>
                     <a:srgbClr val="4D4D4D">
                       <a:alpha val="100000"/>
@@ -4829,14 +4796,14 @@
         </p:sp>
         <p:sp>
           <p:nvSpPr>
-            <p:cNvPr id="60" name="tx60"/>
-            <p:cNvSpPr/>
-            <p:nvPr/>
-          </p:nvSpPr>
-          <p:spPr>
-            <a:xfrm>
-              <a:off x="5284694" y="6064529"/>
-              <a:ext cx="101681" cy="109179"/>
+            <p:cNvPr id="58" name="tx58"/>
+            <p:cNvSpPr/>
+            <p:nvPr/>
+          </p:nvSpPr>
+          <p:spPr>
+            <a:xfrm>
+              <a:off x="5284631" y="6064665"/>
+              <a:ext cx="101649" cy="109091"/>
             </a:xfrm>
             <a:prstGeom prst="rect">
               <a:avLst/>
@@ -4848,6 +4815,9 @@
             <a:lstStyle/>
             <a:p>
               <a:pPr algn="l" marL="0" marR="0" indent="0">
+                <a:lnSpc>
+                  <a:spcPts val="1200"/>
+                </a:lnSpc>
                 <a:spcBef>
                   <a:spcPts val="0"/>
                 </a:spcBef>
@@ -4856,7 +4826,7 @@
                 </a:spcAft>
               </a:pPr>
               <a:r>
-                <a:rPr sz="1200" i="0" b="0">
+                <a:rPr sz="1200">
                   <a:solidFill>
                     <a:srgbClr val="4D4D4D">
                       <a:alpha val="100000"/>
@@ -4872,13 +4842,13 @@
         </p:sp>
         <p:sp>
           <p:nvSpPr>
-            <p:cNvPr id="61" name="pl61"/>
-            <p:cNvSpPr/>
-            <p:nvPr/>
-          </p:nvSpPr>
-          <p:spPr>
-            <a:xfrm>
-              <a:off x="6011109" y="5979125"/>
+            <p:cNvPr id="59" name="pl59"/>
+            <p:cNvSpPr/>
+            <p:nvPr/>
+          </p:nvSpPr>
+          <p:spPr>
+            <a:xfrm>
+              <a:off x="6011043" y="5979261"/>
               <a:ext cx="0" cy="47447"/>
             </a:xfrm>
             <a:custGeom>
@@ -4894,9 +4864,9 @@
                 </a:path>
               </a:pathLst>
             </a:custGeom>
-            <a:ln w="18478" cap="flat">
+            <a:ln w="12737" cap="flat">
               <a:solidFill>
-                <a:srgbClr val="4D4D4D">
+                <a:srgbClr val="000000">
                   <a:alpha val="100000"/>
                 </a:srgbClr>
               </a:solidFill>
@@ -4912,13 +4882,13 @@
         </p:sp>
         <p:sp>
           <p:nvSpPr>
-            <p:cNvPr id="62" name="pl62"/>
-            <p:cNvSpPr/>
-            <p:nvPr/>
-          </p:nvSpPr>
-          <p:spPr>
-            <a:xfrm>
-              <a:off x="6529087" y="5979125"/>
+            <p:cNvPr id="60" name="pl60"/>
+            <p:cNvSpPr/>
+            <p:nvPr/>
+          </p:nvSpPr>
+          <p:spPr>
+            <a:xfrm>
+              <a:off x="6529033" y="5979261"/>
               <a:ext cx="0" cy="47447"/>
             </a:xfrm>
             <a:custGeom>
@@ -4934,9 +4904,9 @@
                 </a:path>
               </a:pathLst>
             </a:custGeom>
-            <a:ln w="18478" cap="flat">
+            <a:ln w="12737" cap="flat">
               <a:solidFill>
-                <a:srgbClr val="4D4D4D">
+                <a:srgbClr val="000000">
                   <a:alpha val="100000"/>
                 </a:srgbClr>
               </a:solidFill>
@@ -4952,13 +4922,13 @@
         </p:sp>
         <p:sp>
           <p:nvSpPr>
-            <p:cNvPr id="63" name="pl63"/>
-            <p:cNvSpPr/>
-            <p:nvPr/>
-          </p:nvSpPr>
-          <p:spPr>
-            <a:xfrm>
-              <a:off x="7047065" y="5979125"/>
+            <p:cNvPr id="61" name="pl61"/>
+            <p:cNvSpPr/>
+            <p:nvPr/>
+          </p:nvSpPr>
+          <p:spPr>
+            <a:xfrm>
+              <a:off x="7047023" y="5979261"/>
               <a:ext cx="0" cy="47447"/>
             </a:xfrm>
             <a:custGeom>
@@ -4974,9 +4944,9 @@
                 </a:path>
               </a:pathLst>
             </a:custGeom>
-            <a:ln w="18478" cap="flat">
+            <a:ln w="12737" cap="flat">
               <a:solidFill>
-                <a:srgbClr val="4D4D4D">
+                <a:srgbClr val="000000">
                   <a:alpha val="100000"/>
                 </a:srgbClr>
               </a:solidFill>
@@ -4992,13 +4962,13 @@
         </p:sp>
         <p:sp>
           <p:nvSpPr>
-            <p:cNvPr id="64" name="pl64"/>
-            <p:cNvSpPr/>
-            <p:nvPr/>
-          </p:nvSpPr>
-          <p:spPr>
-            <a:xfrm>
-              <a:off x="7565044" y="5979125"/>
+            <p:cNvPr id="62" name="pl62"/>
+            <p:cNvSpPr/>
+            <p:nvPr/>
+          </p:nvSpPr>
+          <p:spPr>
+            <a:xfrm>
+              <a:off x="7565013" y="5979261"/>
               <a:ext cx="0" cy="47447"/>
             </a:xfrm>
             <a:custGeom>
@@ -5014,9 +4984,9 @@
                 </a:path>
               </a:pathLst>
             </a:custGeom>
-            <a:ln w="18478" cap="flat">
+            <a:ln w="12737" cap="flat">
               <a:solidFill>
-                <a:srgbClr val="4D4D4D">
+                <a:srgbClr val="000000">
                   <a:alpha val="100000"/>
                 </a:srgbClr>
               </a:solidFill>
@@ -5032,13 +5002,13 @@
         </p:sp>
         <p:sp>
           <p:nvSpPr>
-            <p:cNvPr id="65" name="pl65"/>
-            <p:cNvSpPr/>
-            <p:nvPr/>
-          </p:nvSpPr>
-          <p:spPr>
-            <a:xfrm>
-              <a:off x="8083022" y="5979125"/>
+            <p:cNvPr id="63" name="pl63"/>
+            <p:cNvSpPr/>
+            <p:nvPr/>
+          </p:nvSpPr>
+          <p:spPr>
+            <a:xfrm>
+              <a:off x="8083003" y="5979261"/>
               <a:ext cx="0" cy="47447"/>
             </a:xfrm>
             <a:custGeom>
@@ -5054,9 +5024,9 @@
                 </a:path>
               </a:pathLst>
             </a:custGeom>
-            <a:ln w="18478" cap="flat">
+            <a:ln w="12737" cap="flat">
               <a:solidFill>
-                <a:srgbClr val="4D4D4D">
+                <a:srgbClr val="000000">
                   <a:alpha val="100000"/>
                 </a:srgbClr>
               </a:solidFill>
@@ -5072,13 +5042,13 @@
         </p:sp>
         <p:sp>
           <p:nvSpPr>
-            <p:cNvPr id="66" name="pl66"/>
-            <p:cNvSpPr/>
-            <p:nvPr/>
-          </p:nvSpPr>
-          <p:spPr>
-            <a:xfrm>
-              <a:off x="8601000" y="5979125"/>
+            <p:cNvPr id="64" name="pl64"/>
+            <p:cNvSpPr/>
+            <p:nvPr/>
+          </p:nvSpPr>
+          <p:spPr>
+            <a:xfrm>
+              <a:off x="8600993" y="5979261"/>
               <a:ext cx="0" cy="47447"/>
             </a:xfrm>
             <a:custGeom>
@@ -5094,9 +5064,9 @@
                 </a:path>
               </a:pathLst>
             </a:custGeom>
-            <a:ln w="18478" cap="flat">
+            <a:ln w="12737" cap="flat">
               <a:solidFill>
-                <a:srgbClr val="4D4D4D">
+                <a:srgbClr val="000000">
                   <a:alpha val="100000"/>
                 </a:srgbClr>
               </a:solidFill>
@@ -5112,14 +5082,14 @@
         </p:sp>
         <p:sp>
           <p:nvSpPr>
-            <p:cNvPr id="67" name="tx67"/>
-            <p:cNvSpPr/>
-            <p:nvPr/>
-          </p:nvSpPr>
-          <p:spPr>
-            <a:xfrm>
-              <a:off x="5926344" y="6064529"/>
-              <a:ext cx="169529" cy="109179"/>
+            <p:cNvPr id="65" name="tx65"/>
+            <p:cNvSpPr/>
+            <p:nvPr/>
+          </p:nvSpPr>
+          <p:spPr>
+            <a:xfrm>
+              <a:off x="5926286" y="6064219"/>
+              <a:ext cx="169515" cy="109537"/>
             </a:xfrm>
             <a:prstGeom prst="rect">
               <a:avLst/>
@@ -5131,6 +5101,9 @@
             <a:lstStyle/>
             <a:p>
               <a:pPr algn="l" marL="0" marR="0" indent="0">
+                <a:lnSpc>
+                  <a:spcPts val="1200"/>
+                </a:lnSpc>
                 <a:spcBef>
                   <a:spcPts val="0"/>
                 </a:spcBef>
@@ -5139,7 +5112,7 @@
                 </a:spcAft>
               </a:pPr>
               <a:r>
-                <a:rPr sz="1200" i="0" b="0">
+                <a:rPr sz="1200">
                   <a:solidFill>
                     <a:srgbClr val="4D4D4D">
                       <a:alpha val="100000"/>
@@ -5155,14 +5128,14 @@
         </p:sp>
         <p:sp>
           <p:nvSpPr>
-            <p:cNvPr id="68" name="tx68"/>
-            <p:cNvSpPr/>
-            <p:nvPr/>
-          </p:nvSpPr>
-          <p:spPr>
-            <a:xfrm>
-              <a:off x="6444322" y="6064529"/>
-              <a:ext cx="169529" cy="109179"/>
+            <p:cNvPr id="66" name="tx66"/>
+            <p:cNvSpPr/>
+            <p:nvPr/>
+          </p:nvSpPr>
+          <p:spPr>
+            <a:xfrm>
+              <a:off x="6444276" y="6064219"/>
+              <a:ext cx="169515" cy="109537"/>
             </a:xfrm>
             <a:prstGeom prst="rect">
               <a:avLst/>
@@ -5174,6 +5147,9 @@
             <a:lstStyle/>
             <a:p>
               <a:pPr algn="l" marL="0" marR="0" indent="0">
+                <a:lnSpc>
+                  <a:spcPts val="1200"/>
+                </a:lnSpc>
                 <a:spcBef>
                   <a:spcPts val="0"/>
                 </a:spcBef>
@@ -5182,7 +5158,7 @@
                 </a:spcAft>
               </a:pPr>
               <a:r>
-                <a:rPr sz="1200" i="0" b="0">
+                <a:rPr sz="1200">
                   <a:solidFill>
                     <a:srgbClr val="4D4D4D">
                       <a:alpha val="100000"/>
@@ -5198,14 +5174,14 @@
         </p:sp>
         <p:sp>
           <p:nvSpPr>
-            <p:cNvPr id="69" name="tx69"/>
-            <p:cNvSpPr/>
-            <p:nvPr/>
-          </p:nvSpPr>
-          <p:spPr>
-            <a:xfrm>
-              <a:off x="6962300" y="6064529"/>
-              <a:ext cx="169529" cy="109179"/>
+            <p:cNvPr id="67" name="tx67"/>
+            <p:cNvSpPr/>
+            <p:nvPr/>
+          </p:nvSpPr>
+          <p:spPr>
+            <a:xfrm>
+              <a:off x="6962266" y="6062284"/>
+              <a:ext cx="169515" cy="111472"/>
             </a:xfrm>
             <a:prstGeom prst="rect">
               <a:avLst/>
@@ -5217,6 +5193,9 @@
             <a:lstStyle/>
             <a:p>
               <a:pPr algn="l" marL="0" marR="0" indent="0">
+                <a:lnSpc>
+                  <a:spcPts val="1200"/>
+                </a:lnSpc>
                 <a:spcBef>
                   <a:spcPts val="0"/>
                 </a:spcBef>
@@ -5225,7 +5204,7 @@
                 </a:spcAft>
               </a:pPr>
               <a:r>
-                <a:rPr sz="1200" i="0" b="0">
+                <a:rPr sz="1200">
                   <a:solidFill>
                     <a:srgbClr val="4D4D4D">
                       <a:alpha val="100000"/>
@@ -5241,14 +5220,14 @@
         </p:sp>
         <p:sp>
           <p:nvSpPr>
-            <p:cNvPr id="70" name="tx70"/>
-            <p:cNvSpPr/>
-            <p:nvPr/>
-          </p:nvSpPr>
-          <p:spPr>
-            <a:xfrm>
-              <a:off x="7480279" y="6064529"/>
-              <a:ext cx="169529" cy="109179"/>
+            <p:cNvPr id="68" name="tx68"/>
+            <p:cNvSpPr/>
+            <p:nvPr/>
+          </p:nvSpPr>
+          <p:spPr>
+            <a:xfrm>
+              <a:off x="7480255" y="6064665"/>
+              <a:ext cx="169515" cy="109091"/>
             </a:xfrm>
             <a:prstGeom prst="rect">
               <a:avLst/>
@@ -5260,6 +5239,9 @@
             <a:lstStyle/>
             <a:p>
               <a:pPr algn="l" marL="0" marR="0" indent="0">
+                <a:lnSpc>
+                  <a:spcPts val="1200"/>
+                </a:lnSpc>
                 <a:spcBef>
                   <a:spcPts val="0"/>
                 </a:spcBef>
@@ -5268,7 +5250,7 @@
                 </a:spcAft>
               </a:pPr>
               <a:r>
-                <a:rPr sz="1200" i="0" b="0">
+                <a:rPr sz="1200">
                   <a:solidFill>
                     <a:srgbClr val="4D4D4D">
                       <a:alpha val="100000"/>
@@ -5284,14 +5266,14 @@
         </p:sp>
         <p:sp>
           <p:nvSpPr>
-            <p:cNvPr id="71" name="tx71"/>
-            <p:cNvSpPr/>
-            <p:nvPr/>
-          </p:nvSpPr>
-          <p:spPr>
-            <a:xfrm>
-              <a:off x="7998257" y="6064529"/>
-              <a:ext cx="169529" cy="109179"/>
+            <p:cNvPr id="69" name="tx69"/>
+            <p:cNvSpPr/>
+            <p:nvPr/>
+          </p:nvSpPr>
+          <p:spPr>
+            <a:xfrm>
+              <a:off x="7998245" y="6062805"/>
+              <a:ext cx="169515" cy="110951"/>
             </a:xfrm>
             <a:prstGeom prst="rect">
               <a:avLst/>
@@ -5303,6 +5285,9 @@
             <a:lstStyle/>
             <a:p>
               <a:pPr algn="l" marL="0" marR="0" indent="0">
+                <a:lnSpc>
+                  <a:spcPts val="1200"/>
+                </a:lnSpc>
                 <a:spcBef>
                   <a:spcPts val="0"/>
                 </a:spcBef>
@@ -5311,7 +5296,7 @@
                 </a:spcAft>
               </a:pPr>
               <a:r>
-                <a:rPr sz="1200" i="0" b="0">
+                <a:rPr sz="1200">
                   <a:solidFill>
                     <a:srgbClr val="4D4D4D">
                       <a:alpha val="100000"/>
@@ -5327,14 +5312,14 @@
         </p:sp>
         <p:sp>
           <p:nvSpPr>
-            <p:cNvPr id="72" name="tx72"/>
-            <p:cNvSpPr/>
-            <p:nvPr/>
-          </p:nvSpPr>
-          <p:spPr>
-            <a:xfrm>
-              <a:off x="8550159" y="6064529"/>
-              <a:ext cx="101681" cy="109179"/>
+            <p:cNvPr id="70" name="tx70"/>
+            <p:cNvSpPr/>
+            <p:nvPr/>
+          </p:nvSpPr>
+          <p:spPr>
+            <a:xfrm>
+              <a:off x="8550168" y="6064665"/>
+              <a:ext cx="101649" cy="109091"/>
             </a:xfrm>
             <a:prstGeom prst="rect">
               <a:avLst/>
@@ -5346,6 +5331,9 @@
             <a:lstStyle/>
             <a:p>
               <a:pPr algn="l" marL="0" marR="0" indent="0">
+                <a:lnSpc>
+                  <a:spcPts val="1200"/>
+                </a:lnSpc>
                 <a:spcBef>
                   <a:spcPts val="0"/>
                 </a:spcBef>
@@ -5354,7 +5342,7 @@
                 </a:spcAft>
               </a:pPr>
               <a:r>
-                <a:rPr sz="1200" i="0" b="0">
+                <a:rPr sz="1200">
                   <a:solidFill>
                     <a:srgbClr val="4D4D4D">
                       <a:alpha val="100000"/>
@@ -5370,14 +5358,14 @@
         </p:sp>
         <p:sp>
           <p:nvSpPr>
-            <p:cNvPr id="73" name="tx73"/>
-            <p:cNvSpPr/>
-            <p:nvPr/>
-          </p:nvSpPr>
-          <p:spPr>
-            <a:xfrm>
-              <a:off x="2264688" y="5924535"/>
-              <a:ext cx="84764" cy="109179"/>
+            <p:cNvPr id="71" name="tx71"/>
+            <p:cNvSpPr/>
+            <p:nvPr/>
+          </p:nvSpPr>
+          <p:spPr>
+            <a:xfrm>
+              <a:off x="2264549" y="5922408"/>
+              <a:ext cx="84757" cy="111397"/>
             </a:xfrm>
             <a:prstGeom prst="rect">
               <a:avLst/>
@@ -5389,6 +5377,9 @@
             <a:lstStyle/>
             <a:p>
               <a:pPr algn="l" marL="0" marR="0" indent="0">
+                <a:lnSpc>
+                  <a:spcPts val="1200"/>
+                </a:lnSpc>
                 <a:spcBef>
                   <a:spcPts val="0"/>
                 </a:spcBef>
@@ -5397,7 +5388,7 @@
                 </a:spcAft>
               </a:pPr>
               <a:r>
-                <a:rPr sz="1200" i="0" b="0">
+                <a:rPr sz="1200">
                   <a:solidFill>
                     <a:srgbClr val="4D4D4D">
                       <a:alpha val="100000"/>
@@ -5413,14 +5404,14 @@
         </p:sp>
         <p:sp>
           <p:nvSpPr>
-            <p:cNvPr id="74" name="tx74"/>
-            <p:cNvSpPr/>
-            <p:nvPr/>
-          </p:nvSpPr>
-          <p:spPr>
-            <a:xfrm>
-              <a:off x="2010393" y="4715027"/>
-              <a:ext cx="339059" cy="109179"/>
+            <p:cNvPr id="72" name="tx72"/>
+            <p:cNvSpPr/>
+            <p:nvPr/>
+          </p:nvSpPr>
+          <p:spPr>
+            <a:xfrm>
+              <a:off x="2010277" y="4712849"/>
+              <a:ext cx="339030" cy="111397"/>
             </a:xfrm>
             <a:prstGeom prst="rect">
               <a:avLst/>
@@ -5432,6 +5423,9 @@
             <a:lstStyle/>
             <a:p>
               <a:pPr algn="l" marL="0" marR="0" indent="0">
+                <a:lnSpc>
+                  <a:spcPts val="1200"/>
+                </a:lnSpc>
                 <a:spcBef>
                   <a:spcPts val="0"/>
                 </a:spcBef>
@@ -5440,7 +5434,7 @@
                 </a:spcAft>
               </a:pPr>
               <a:r>
-                <a:rPr sz="1200" i="0" b="0">
+                <a:rPr sz="1200">
                   <a:solidFill>
                     <a:srgbClr val="4D4D4D">
                       <a:alpha val="100000"/>
@@ -5456,14 +5450,14 @@
         </p:sp>
         <p:sp>
           <p:nvSpPr>
-            <p:cNvPr id="75" name="tx75"/>
-            <p:cNvSpPr/>
-            <p:nvPr/>
-          </p:nvSpPr>
-          <p:spPr>
-            <a:xfrm>
-              <a:off x="2010393" y="3505519"/>
-              <a:ext cx="339059" cy="109179"/>
+            <p:cNvPr id="73" name="tx73"/>
+            <p:cNvSpPr/>
+            <p:nvPr/>
+          </p:nvSpPr>
+          <p:spPr>
+            <a:xfrm>
+              <a:off x="2010277" y="3503289"/>
+              <a:ext cx="339030" cy="111397"/>
             </a:xfrm>
             <a:prstGeom prst="rect">
               <a:avLst/>
@@ -5475,6 +5469,9 @@
             <a:lstStyle/>
             <a:p>
               <a:pPr algn="l" marL="0" marR="0" indent="0">
+                <a:lnSpc>
+                  <a:spcPts val="1200"/>
+                </a:lnSpc>
                 <a:spcBef>
                   <a:spcPts val="0"/>
                 </a:spcBef>
@@ -5483,7 +5480,7 @@
                 </a:spcAft>
               </a:pPr>
               <a:r>
-                <a:rPr sz="1200" i="0" b="0">
+                <a:rPr sz="1200">
                   <a:solidFill>
                     <a:srgbClr val="4D4D4D">
                       <a:alpha val="100000"/>
@@ -5499,14 +5496,14 @@
         </p:sp>
         <p:sp>
           <p:nvSpPr>
-            <p:cNvPr id="76" name="tx76"/>
-            <p:cNvSpPr/>
-            <p:nvPr/>
-          </p:nvSpPr>
-          <p:spPr>
-            <a:xfrm>
-              <a:off x="2010393" y="2296012"/>
-              <a:ext cx="339059" cy="109179"/>
+            <p:cNvPr id="74" name="tx74"/>
+            <p:cNvSpPr/>
+            <p:nvPr/>
+          </p:nvSpPr>
+          <p:spPr>
+            <a:xfrm>
+              <a:off x="2010277" y="2293655"/>
+              <a:ext cx="339030" cy="111472"/>
             </a:xfrm>
             <a:prstGeom prst="rect">
               <a:avLst/>
@@ -5518,6 +5515,9 @@
             <a:lstStyle/>
             <a:p>
               <a:pPr algn="l" marL="0" marR="0" indent="0">
+                <a:lnSpc>
+                  <a:spcPts val="1200"/>
+                </a:lnSpc>
                 <a:spcBef>
                   <a:spcPts val="0"/>
                 </a:spcBef>
@@ -5526,7 +5526,7 @@
                 </a:spcAft>
               </a:pPr>
               <a:r>
-                <a:rPr sz="1200" i="0" b="0">
+                <a:rPr sz="1200">
                   <a:solidFill>
                     <a:srgbClr val="4D4D4D">
                       <a:alpha val="100000"/>
@@ -5542,13 +5542,13 @@
         </p:sp>
         <p:sp>
           <p:nvSpPr>
-            <p:cNvPr id="77" name="pl77"/>
-            <p:cNvSpPr/>
-            <p:nvPr/>
-          </p:nvSpPr>
-          <p:spPr>
-            <a:xfrm>
-              <a:off x="2387410" y="5979125"/>
+            <p:cNvPr id="75" name="pl75"/>
+            <p:cNvSpPr/>
+            <p:nvPr/>
+          </p:nvSpPr>
+          <p:spPr>
+            <a:xfrm>
+              <a:off x="2387265" y="5979261"/>
               <a:ext cx="47447" cy="0"/>
             </a:xfrm>
             <a:custGeom>
@@ -5564,9 +5564,9 @@
                 </a:path>
               </a:pathLst>
             </a:custGeom>
-            <a:ln w="18478" cap="flat">
+            <a:ln w="12737" cap="flat">
               <a:solidFill>
-                <a:srgbClr val="4D4D4D">
+                <a:srgbClr val="000000">
                   <a:alpha val="100000"/>
                 </a:srgbClr>
               </a:solidFill>
@@ -5582,13 +5582,13 @@
         </p:sp>
         <p:sp>
           <p:nvSpPr>
-            <p:cNvPr id="78" name="pl78"/>
-            <p:cNvSpPr/>
-            <p:nvPr/>
-          </p:nvSpPr>
-          <p:spPr>
-            <a:xfrm>
-              <a:off x="2387410" y="4769617"/>
+            <p:cNvPr id="76" name="pl76"/>
+            <p:cNvSpPr/>
+            <p:nvPr/>
+          </p:nvSpPr>
+          <p:spPr>
+            <a:xfrm>
+              <a:off x="2387265" y="4769701"/>
               <a:ext cx="47447" cy="0"/>
             </a:xfrm>
             <a:custGeom>
@@ -5604,9 +5604,9 @@
                 </a:path>
               </a:pathLst>
             </a:custGeom>
-            <a:ln w="18478" cap="flat">
+            <a:ln w="12737" cap="flat">
               <a:solidFill>
-                <a:srgbClr val="4D4D4D">
+                <a:srgbClr val="000000">
                   <a:alpha val="100000"/>
                 </a:srgbClr>
               </a:solidFill>
@@ -5622,13 +5622,13 @@
         </p:sp>
         <p:sp>
           <p:nvSpPr>
-            <p:cNvPr id="79" name="pl79"/>
-            <p:cNvSpPr/>
-            <p:nvPr/>
-          </p:nvSpPr>
-          <p:spPr>
-            <a:xfrm>
-              <a:off x="2387410" y="3560109"/>
+            <p:cNvPr id="77" name="pl77"/>
+            <p:cNvSpPr/>
+            <p:nvPr/>
+          </p:nvSpPr>
+          <p:spPr>
+            <a:xfrm>
+              <a:off x="2387265" y="3560141"/>
               <a:ext cx="47447" cy="0"/>
             </a:xfrm>
             <a:custGeom>
@@ -5644,9 +5644,9 @@
                 </a:path>
               </a:pathLst>
             </a:custGeom>
-            <a:ln w="18478" cap="flat">
+            <a:ln w="12737" cap="flat">
               <a:solidFill>
-                <a:srgbClr val="4D4D4D">
+                <a:srgbClr val="000000">
                   <a:alpha val="100000"/>
                 </a:srgbClr>
               </a:solidFill>
@@ -5662,13 +5662,13 @@
         </p:sp>
         <p:sp>
           <p:nvSpPr>
-            <p:cNvPr id="80" name="pl80"/>
-            <p:cNvSpPr/>
-            <p:nvPr/>
-          </p:nvSpPr>
-          <p:spPr>
-            <a:xfrm>
-              <a:off x="2387410" y="2350601"/>
+            <p:cNvPr id="78" name="pl78"/>
+            <p:cNvSpPr/>
+            <p:nvPr/>
+          </p:nvSpPr>
+          <p:spPr>
+            <a:xfrm>
+              <a:off x="2387265" y="2350582"/>
               <a:ext cx="47447" cy="0"/>
             </a:xfrm>
             <a:custGeom>
@@ -5684,9 +5684,9 @@
                 </a:path>
               </a:pathLst>
             </a:custGeom>
-            <a:ln w="18478" cap="flat">
+            <a:ln w="12737" cap="flat">
               <a:solidFill>
-                <a:srgbClr val="4D4D4D">
+                <a:srgbClr val="000000">
                   <a:alpha val="100000"/>
                 </a:srgbClr>
               </a:solidFill>
@@ -5702,14 +5702,14 @@
         </p:sp>
         <p:sp>
           <p:nvSpPr>
-            <p:cNvPr id="81" name="tx81"/>
-            <p:cNvSpPr/>
-            <p:nvPr/>
-          </p:nvSpPr>
-          <p:spPr>
-            <a:xfrm>
-              <a:off x="5424514" y="6253160"/>
-              <a:ext cx="497616" cy="136428"/>
+            <p:cNvPr id="79" name="tx79"/>
+            <p:cNvSpPr/>
+            <p:nvPr/>
+          </p:nvSpPr>
+          <p:spPr>
+            <a:xfrm>
+              <a:off x="5424334" y="6210860"/>
+              <a:ext cx="497830" cy="178779"/>
             </a:xfrm>
             <a:prstGeom prst="rect">
               <a:avLst/>
@@ -5721,6 +5721,9 @@
             <a:lstStyle/>
             <a:p>
               <a:pPr algn="l" marL="0" marR="0" indent="0">
+                <a:lnSpc>
+                  <a:spcPts val="1500"/>
+                </a:lnSpc>
                 <a:spcBef>
                   <a:spcPts val="0"/>
                 </a:spcBef>
@@ -5729,7 +5732,7 @@
                 </a:spcAft>
               </a:pPr>
               <a:r>
-                <a:rPr sz="1500" i="0" b="0">
+                <a:rPr sz="1500">
                   <a:solidFill>
                     <a:srgbClr val="000000">
                       <a:alpha val="100000"/>
@@ -5745,14 +5748,14 @@
         </p:sp>
         <p:sp>
           <p:nvSpPr>
-            <p:cNvPr id="82" name="tx82"/>
+            <p:cNvPr id="80" name="tx80"/>
             <p:cNvSpPr/>
             <p:nvPr/>
           </p:nvSpPr>
           <p:spPr>
             <a:xfrm rot="-5400000">
-              <a:off x="965427" y="3657960"/>
-              <a:ext cx="1778325" cy="136428"/>
+              <a:off x="943915" y="3636824"/>
+              <a:ext cx="1778868" cy="178779"/>
             </a:xfrm>
             <a:prstGeom prst="rect">
               <a:avLst/>
@@ -5764,6 +5767,9 @@
             <a:lstStyle/>
             <a:p>
               <a:pPr algn="l" marL="0" marR="0" indent="0">
+                <a:lnSpc>
+                  <a:spcPts val="1500"/>
+                </a:lnSpc>
                 <a:spcBef>
                   <a:spcPts val="0"/>
                 </a:spcBef>
@@ -5772,7 +5778,7 @@
                 </a:spcAft>
               </a:pPr>
               <a:r>
-                <a:rPr sz="1500" i="0" b="0">
+                <a:rPr sz="1500">
                   <a:solidFill>
                     <a:srgbClr val="000000">
                       <a:alpha val="100000"/>
@@ -5788,19 +5794,18 @@
         </p:sp>
         <p:sp>
           <p:nvSpPr>
-            <p:cNvPr id="83" name="rc83"/>
-            <p:cNvSpPr/>
-            <p:nvPr/>
-          </p:nvSpPr>
-          <p:spPr>
-            <a:xfrm>
-              <a:off x="3695599" y="2108826"/>
+            <p:cNvPr id="81" name="rc81"/>
+            <p:cNvSpPr/>
+            <p:nvPr/>
+          </p:nvSpPr>
+          <p:spPr>
+            <a:xfrm>
+              <a:off x="3695479" y="2203687"/>
               <a:ext cx="198000" cy="198000"/>
             </a:xfrm>
             <a:prstGeom prst="rect">
               <a:avLst/>
             </a:prstGeom>
-            <a:noFill/>
           </p:spPr>
           <p:txBody>
             <a:bodyPr/>
@@ -5810,14 +5815,14 @@
         </p:sp>
         <p:sp>
           <p:nvSpPr>
-            <p:cNvPr id="84" name="rc84"/>
-            <p:cNvSpPr/>
-            <p:nvPr/>
-          </p:nvSpPr>
-          <p:spPr>
-            <a:xfrm>
-              <a:off x="3707871" y="2121099"/>
-              <a:ext cx="173454" cy="173454"/>
+            <p:cNvPr id="82" name="rc82"/>
+            <p:cNvSpPr/>
+            <p:nvPr/>
+          </p:nvSpPr>
+          <p:spPr>
+            <a:xfrm>
+              <a:off x="3704479" y="2212687"/>
+              <a:ext cx="179999" cy="179999"/>
             </a:xfrm>
             <a:prstGeom prst="rect">
               <a:avLst/>
@@ -5836,19 +5841,18 @@
         </p:sp>
         <p:sp>
           <p:nvSpPr>
-            <p:cNvPr id="85" name="rc85"/>
-            <p:cNvSpPr/>
-            <p:nvPr/>
-          </p:nvSpPr>
-          <p:spPr>
-            <a:xfrm>
-              <a:off x="3695599" y="2306826"/>
+            <p:cNvPr id="83" name="rc83"/>
+            <p:cNvSpPr/>
+            <p:nvPr/>
+          </p:nvSpPr>
+          <p:spPr>
+            <a:xfrm>
+              <a:off x="3695479" y="2401687"/>
               <a:ext cx="198000" cy="198000"/>
             </a:xfrm>
             <a:prstGeom prst="rect">
               <a:avLst/>
             </a:prstGeom>
-            <a:noFill/>
           </p:spPr>
           <p:txBody>
             <a:bodyPr/>
@@ -5858,14 +5862,14 @@
         </p:sp>
         <p:sp>
           <p:nvSpPr>
-            <p:cNvPr id="86" name="rc86"/>
-            <p:cNvSpPr/>
-            <p:nvPr/>
-          </p:nvSpPr>
-          <p:spPr>
-            <a:xfrm>
-              <a:off x="3707871" y="2319099"/>
-              <a:ext cx="173454" cy="173454"/>
+            <p:cNvPr id="84" name="rc84"/>
+            <p:cNvSpPr/>
+            <p:nvPr/>
+          </p:nvSpPr>
+          <p:spPr>
+            <a:xfrm>
+              <a:off x="3704479" y="2410687"/>
+              <a:ext cx="179999" cy="179999"/>
             </a:xfrm>
             <a:prstGeom prst="rect">
               <a:avLst/>
@@ -5884,19 +5888,18 @@
         </p:sp>
         <p:sp>
           <p:nvSpPr>
-            <p:cNvPr id="87" name="rc87"/>
-            <p:cNvSpPr/>
-            <p:nvPr/>
-          </p:nvSpPr>
-          <p:spPr>
-            <a:xfrm>
-              <a:off x="3695599" y="2504826"/>
+            <p:cNvPr id="85" name="rc85"/>
+            <p:cNvSpPr/>
+            <p:nvPr/>
+          </p:nvSpPr>
+          <p:spPr>
+            <a:xfrm>
+              <a:off x="3695479" y="2599687"/>
               <a:ext cx="198000" cy="198000"/>
             </a:xfrm>
             <a:prstGeom prst="rect">
               <a:avLst/>
             </a:prstGeom>
-            <a:noFill/>
           </p:spPr>
           <p:txBody>
             <a:bodyPr/>
@@ -5906,14 +5909,14 @@
         </p:sp>
         <p:sp>
           <p:nvSpPr>
-            <p:cNvPr id="88" name="rc88"/>
-            <p:cNvSpPr/>
-            <p:nvPr/>
-          </p:nvSpPr>
-          <p:spPr>
-            <a:xfrm>
-              <a:off x="3707871" y="2517099"/>
-              <a:ext cx="173454" cy="173454"/>
+            <p:cNvPr id="86" name="rc86"/>
+            <p:cNvSpPr/>
+            <p:nvPr/>
+          </p:nvSpPr>
+          <p:spPr>
+            <a:xfrm>
+              <a:off x="3704479" y="2608687"/>
+              <a:ext cx="179999" cy="179999"/>
             </a:xfrm>
             <a:prstGeom prst="rect">
               <a:avLst/>
@@ -5932,14 +5935,14 @@
         </p:sp>
         <p:sp>
           <p:nvSpPr>
-            <p:cNvPr id="89" name="tx89"/>
-            <p:cNvSpPr/>
-            <p:nvPr/>
-          </p:nvSpPr>
-          <p:spPr>
-            <a:xfrm>
-              <a:off x="3988493" y="2153237"/>
-              <a:ext cx="482894" cy="109179"/>
+            <p:cNvPr id="87" name="tx87"/>
+            <p:cNvSpPr/>
+            <p:nvPr/>
+          </p:nvSpPr>
+          <p:spPr>
+            <a:xfrm>
+              <a:off x="3988374" y="2246355"/>
+              <a:ext cx="482724" cy="110876"/>
             </a:xfrm>
             <a:prstGeom prst="rect">
               <a:avLst/>
@@ -5951,6 +5954,9 @@
             <a:lstStyle/>
             <a:p>
               <a:pPr algn="l" marL="0" marR="0" indent="0">
+                <a:lnSpc>
+                  <a:spcPts val="1200"/>
+                </a:lnSpc>
                 <a:spcBef>
                   <a:spcPts val="0"/>
                 </a:spcBef>
@@ -5959,7 +5965,7 @@
                 </a:spcAft>
               </a:pPr>
               <a:r>
-                <a:rPr sz="1200" i="0" b="0">
+                <a:rPr sz="1200">
                   <a:solidFill>
                     <a:srgbClr val="000000">
                       <a:alpha val="100000"/>
@@ -5975,14 +5981,14 @@
         </p:sp>
         <p:sp>
           <p:nvSpPr>
-            <p:cNvPr id="90" name="tx90"/>
-            <p:cNvSpPr/>
-            <p:nvPr/>
-          </p:nvSpPr>
-          <p:spPr>
-            <a:xfrm>
-              <a:off x="3988493" y="2351237"/>
-              <a:ext cx="1152235" cy="109179"/>
+            <p:cNvPr id="88" name="tx88"/>
+            <p:cNvSpPr/>
+            <p:nvPr/>
+          </p:nvSpPr>
+          <p:spPr>
+            <a:xfrm>
+              <a:off x="3988374" y="2414069"/>
+              <a:ext cx="1152152" cy="141163"/>
             </a:xfrm>
             <a:prstGeom prst="rect">
               <a:avLst/>
@@ -5994,6 +6000,9 @@
             <a:lstStyle/>
             <a:p>
               <a:pPr algn="l" marL="0" marR="0" indent="0">
+                <a:lnSpc>
+                  <a:spcPts val="1200"/>
+                </a:lnSpc>
                 <a:spcBef>
                   <a:spcPts val="0"/>
                 </a:spcBef>
@@ -6002,7 +6011,7 @@
                 </a:spcAft>
               </a:pPr>
               <a:r>
-                <a:rPr sz="1200" i="0" b="0">
+                <a:rPr sz="1200">
                   <a:solidFill>
                     <a:srgbClr val="000000">
                       <a:alpha val="100000"/>
@@ -6018,14 +6027,14 @@
         </p:sp>
         <p:sp>
           <p:nvSpPr>
-            <p:cNvPr id="91" name="tx91"/>
-            <p:cNvSpPr/>
-            <p:nvPr/>
-          </p:nvSpPr>
-          <p:spPr>
-            <a:xfrm>
-              <a:off x="3988493" y="2549237"/>
-              <a:ext cx="940368" cy="109179"/>
+            <p:cNvPr id="89" name="tx89"/>
+            <p:cNvSpPr/>
+            <p:nvPr/>
+          </p:nvSpPr>
+          <p:spPr>
+            <a:xfrm>
+              <a:off x="3988374" y="2612069"/>
+              <a:ext cx="940296" cy="141163"/>
             </a:xfrm>
             <a:prstGeom prst="rect">
               <a:avLst/>
@@ -6037,6 +6046,9 @@
             <a:lstStyle/>
             <a:p>
               <a:pPr algn="l" marL="0" marR="0" indent="0">
+                <a:lnSpc>
+                  <a:spcPts val="1200"/>
+                </a:lnSpc>
                 <a:spcBef>
                   <a:spcPts val="0"/>
                 </a:spcBef>
@@ -6045,7 +6057,7 @@
                 </a:spcAft>
               </a:pPr>
               <a:r>
-                <a:rPr sz="1200" i="0" b="0">
+                <a:rPr sz="1200">
                   <a:solidFill>
                     <a:srgbClr val="000000">
                       <a:alpha val="100000"/>

</xml_diff>